<commit_message>
Add 'Beyond Power Electronics' methodology-transfer section
  Strategic addition - chooses framework sketches over fake full models
  to preserve calibrated honesty while showing cross-sector applicability
  of the decomposition reflex.
  
  Changes:
  - content/01-page-content.md: new section 5 with three sketches
    (semis / medtech / grid). Each sketch lists sub-sectors and
    dispersion drivers without committing to stress numbers.
  - slides/UniCredit-FirstLook-Deck.pptx: new slide 11 with the three
    sketches in a 3-column layout. Deck grows from 12 to 13.
  - code/build_deck.py: slide_11_beyond() function; renumbered.
</commit_message>
<xml_diff>
--- a/slides/UniCredit-FirstLook-Deck.pptx
+++ b/slides/UniCredit-FirstLook-Deck.pptx
@@ -17,6 +17,7 @@
     <p:sldId id="265" r:id="rId16"/>
     <p:sldId id="266" r:id="rId17"/>
     <p:sldId id="267" r:id="rId18"/>
+    <p:sldId id="268" r:id="rId19"/>
   </p:sldIdLst>
   <p:sldSz cx="12191695" cy="6858000" type="screen4x3"/>
   <p:notesSz cx="6858000" cy="9144000"/>
@@ -3817,7 +3818,7 @@
                 </a:solidFill>
                 <a:latin typeface="Helvetica Neue"/>
               </a:rPr>
-              <a:t>10 / 12</a:t>
+              <a:t>10 / 13</a:t>
             </a:r>
           </a:p>
         </p:txBody>
@@ -4330,7 +4331,7 @@
                 </a:solidFill>
                 <a:latin typeface="Helvetica Neue"/>
               </a:rPr>
-              <a:t>09  ·  ABOUT ME</a:t>
+              <a:t>09  ·  METHODOLOGY TRANSFER</a:t>
             </a:r>
           </a:p>
         </p:txBody>
@@ -4369,7 +4370,7 @@
                 </a:solidFill>
                 <a:latin typeface="Helvetica Neue"/>
               </a:rPr>
-              <a:t>An engineer applying to a non-engineering seat</a:t>
+              <a:t>The reflex extends beyond power electronics</a:t>
             </a:r>
           </a:p>
         </p:txBody>
@@ -4517,156 +4518,21 @@
                 </a:solidFill>
                 <a:latin typeface="Helvetica Neue"/>
               </a:rPr>
-              <a:t>11 / 12</a:t>
-            </a:r>
-          </a:p>
-        </p:txBody>
-      </p:sp>
-      <p:sp>
-        <p:nvSpPr>
-          <p:cNvPr id="9" name="TextBox 8"/>
-          <p:cNvSpPr txBox="1"/>
-          <p:nvPr/>
-        </p:nvSpPr>
-        <p:spPr>
-          <a:xfrm>
-            <a:off x="502920" y="1783080"/>
-            <a:ext cx="6400800" cy="365760"/>
-          </a:xfrm>
-          <a:prstGeom prst="rect">
-            <a:avLst/>
-          </a:prstGeom>
-          <a:noFill/>
-        </p:spPr>
-        <p:txBody>
-          <a:bodyPr wrap="square" anchor="t" lIns="0" rIns="0" tIns="0" bIns="0">
-            <a:spAutoFit/>
-          </a:bodyPr>
-          <a:lstStyle/>
-          <a:p>
-            <a:pPr algn="l">
-              <a:lnSpc>
-                <a:spcPct val="115000"/>
-              </a:lnSpc>
-            </a:pPr>
-            <a:r>
-              <a:rPr sz="1000" b="1" i="0">
-                <a:solidFill>
-                  <a:srgbClr val="B6142E"/>
-                </a:solidFill>
-                <a:latin typeface="Helvetica Neue"/>
-              </a:rPr>
-              <a:t>BACKGROUND</a:t>
-            </a:r>
-          </a:p>
-        </p:txBody>
-      </p:sp>
-      <p:sp>
-        <p:nvSpPr>
-          <p:cNvPr id="10" name="TextBox 9"/>
-          <p:cNvSpPr txBox="1"/>
-          <p:nvPr/>
-        </p:nvSpPr>
-        <p:spPr>
-          <a:xfrm>
-            <a:off x="502920" y="2148840"/>
-            <a:ext cx="6400800" cy="3840480"/>
-          </a:xfrm>
-          <a:prstGeom prst="rect">
-            <a:avLst/>
-          </a:prstGeom>
-          <a:noFill/>
-        </p:spPr>
-        <p:txBody>
-          <a:bodyPr wrap="square" anchor="t" lIns="0" rIns="0" tIns="0" bIns="0">
-            <a:spAutoFit/>
-          </a:bodyPr>
-          <a:lstStyle/>
-          <a:p>
-            <a:pPr algn="l">
-              <a:lnSpc>
-                <a:spcPct val="115000"/>
-              </a:lnSpc>
-            </a:pPr>
-            <a:r>
-              <a:rPr sz="1200" b="0" i="0">
-                <a:solidFill>
-                  <a:srgbClr val="1B1F29"/>
-                </a:solidFill>
-                <a:latin typeface="Helvetica Neue"/>
-              </a:rPr>
-              <a:t/>
-            </a:r>
-          </a:p>
-          <a:p>
-            <a:pPr algn="l">
-              <a:lnSpc>
-                <a:spcPct val="135000"/>
-              </a:lnSpc>
-              <a:spcBef>
-                <a:spcPts val="0"/>
-              </a:spcBef>
-            </a:pPr>
-            <a:r>
-              <a:rPr sz="1250" b="0" i="0">
-                <a:solidFill>
-                  <a:srgbClr val="1B1F29"/>
-                </a:solidFill>
-                <a:latin typeface="Helvetica Neue"/>
-              </a:rPr>
-              <a:t>EE M.Sc. candidate at Politecnico di Milano, technical concentration in power electronics and control.</a:t>
-            </a:r>
-          </a:p>
-          <a:p>
-            <a:pPr algn="l">
-              <a:lnSpc>
-                <a:spcPct val="135000"/>
-              </a:lnSpc>
-              <a:spcBef>
-                <a:spcPts val="1000"/>
-              </a:spcBef>
-            </a:pPr>
-            <a:r>
-              <a:rPr sz="1250" b="0" i="0">
-                <a:solidFill>
-                  <a:srgbClr val="1B1F29"/>
-                </a:solidFill>
-                <a:latin typeface="Helvetica Neue"/>
-              </a:rPr>
-              <a:t>Most recent project: EMI filter design for a switched-mode converter — direct hands-on exposure to the components and end-markets PE capital is currently flowing into.</a:t>
-            </a:r>
-          </a:p>
-          <a:p>
-            <a:pPr algn="l">
-              <a:lnSpc>
-                <a:spcPct val="135000"/>
-              </a:lnSpc>
-              <a:spcBef>
-                <a:spcPts val="1000"/>
-              </a:spcBef>
-            </a:pPr>
-            <a:r>
-              <a:rPr sz="1250" b="0" i="0">
-                <a:solidFill>
-                  <a:srgbClr val="1B1F29"/>
-                </a:solidFill>
-                <a:latin typeface="Helvetica Neue"/>
-              </a:rPr>
-              <a:t>Why fund finance, why now: the analytical reflexes from EE — sensitivity, decomposition, stress testing — are the same ones NAV underwriting needs. And the sectors where NAV facilities are growing fastest in 2026 are exactly the ones where engineering literacy at the desk would differentiate the bank.</a:t>
-            </a:r>
-          </a:p>
-        </p:txBody>
-      </p:sp>
-      <p:sp>
-        <p:nvSpPr>
-          <p:cNvPr id="11" name="Rectangle 10"/>
+              <a:t>11 / 13</a:t>
+            </a:r>
+          </a:p>
+        </p:txBody>
+      </p:sp>
+      <p:sp>
+        <p:nvSpPr>
+          <p:cNvPr id="9" name="Rectangle 8"/>
           <p:cNvSpPr/>
           <p:nvPr/>
         </p:nvSpPr>
         <p:spPr>
           <a:xfrm>
-            <a:off x="7315200" y="1783080"/>
-            <a:ext cx="4389120" cy="4160520"/>
+            <a:off x="502920" y="1645920"/>
+            <a:ext cx="11155680" cy="777240"/>
           </a:xfrm>
           <a:prstGeom prst="rect">
             <a:avLst/>
@@ -4703,14 +4569,14 @@
       </p:sp>
       <p:sp>
         <p:nvSpPr>
-          <p:cNvPr id="12" name="TextBox 11"/>
-          <p:cNvSpPr txBox="1"/>
-          <p:nvPr/>
-        </p:nvSpPr>
-        <p:spPr>
-          <a:xfrm>
-            <a:off x="7543800" y="1920240"/>
-            <a:ext cx="4114800" cy="320040"/>
+          <p:cNvPr id="10" name="TextBox 9"/>
+          <p:cNvSpPr txBox="1"/>
+          <p:nvPr/>
+        </p:nvSpPr>
+        <p:spPr>
+          <a:xfrm>
+            <a:off x="777240" y="1783080"/>
+            <a:ext cx="10607040" cy="274320"/>
           </a:xfrm>
           <a:prstGeom prst="rect">
             <a:avLst/>
@@ -4731,296 +4597,1297 @@
             <a:r>
               <a:rPr sz="1000" b="1" i="0">
                 <a:solidFill>
-                  <a:srgbClr val="1F7A3C"/>
-                </a:solidFill>
-                <a:latin typeface="Helvetica Neue"/>
-              </a:rPr>
-              <a:t>WHAT I BRING</a:t>
-            </a:r>
-          </a:p>
-        </p:txBody>
-      </p:sp>
-      <p:sp>
-        <p:nvSpPr>
-          <p:cNvPr id="13" name="TextBox 12"/>
-          <p:cNvSpPr txBox="1"/>
-          <p:nvPr/>
-        </p:nvSpPr>
-        <p:spPr>
-          <a:xfrm>
-            <a:off x="7543800" y="2286000"/>
-            <a:ext cx="4023360" cy="1554480"/>
-          </a:xfrm>
-          <a:prstGeom prst="rect">
-            <a:avLst/>
-          </a:prstGeom>
-          <a:noFill/>
-        </p:spPr>
-        <p:txBody>
-          <a:bodyPr wrap="square" anchor="t" lIns="0" rIns="0" tIns="0" bIns="0">
-            <a:spAutoFit/>
-          </a:bodyPr>
-          <a:lstStyle/>
-          <a:p>
-            <a:pPr algn="l">
-              <a:lnSpc>
-                <a:spcPct val="115000"/>
-              </a:lnSpc>
-            </a:pPr>
-            <a:r>
-              <a:rPr sz="1100" b="0" i="0">
+                  <a:srgbClr val="B6142E"/>
+                </a:solidFill>
+                <a:latin typeface="Helvetica Neue"/>
+              </a:rPr>
+              <a:t>THESIS</a:t>
+            </a:r>
+          </a:p>
+        </p:txBody>
+      </p:sp>
+      <p:sp>
+        <p:nvSpPr>
+          <p:cNvPr id="11" name="TextBox 10"/>
+          <p:cNvSpPr txBox="1"/>
+          <p:nvPr/>
+        </p:nvSpPr>
+        <p:spPr>
+          <a:xfrm>
+            <a:off x="777240" y="2011680"/>
+            <a:ext cx="10607040" cy="502920"/>
+          </a:xfrm>
+          <a:prstGeom prst="rect">
+            <a:avLst/>
+          </a:prstGeom>
+          <a:noFill/>
+        </p:spPr>
+        <p:txBody>
+          <a:bodyPr wrap="square" anchor="t" lIns="0" rIns="0" tIns="0" bIns="0">
+            <a:spAutoFit/>
+          </a:bodyPr>
+          <a:lstStyle/>
+          <a:p>
+            <a:pPr algn="l">
+              <a:lnSpc>
+                <a:spcPct val="135000"/>
+              </a:lnSpc>
+            </a:pPr>
+            <a:r>
+              <a:rPr sz="1200" b="0" i="1">
                 <a:solidFill>
                   <a:srgbClr val="1B1F29"/>
                 </a:solidFill>
                 <a:latin typeface="Helvetica Neue"/>
               </a:rPr>
+              <a:t>The decomposition reflex is not specific to power electronics. Three sketches — sectors where the same approach applies, deliberately without numbers to avoid claiming expertise I don't yet have.</a:t>
+            </a:r>
+          </a:p>
+        </p:txBody>
+      </p:sp>
+      <p:sp>
+        <p:nvSpPr>
+          <p:cNvPr id="12" name="Rectangle 11"/>
+          <p:cNvSpPr/>
+          <p:nvPr/>
+        </p:nvSpPr>
+        <p:spPr>
+          <a:xfrm>
+            <a:off x="502920" y="2606040"/>
+            <a:ext cx="3657600" cy="3017520"/>
+          </a:xfrm>
+          <a:prstGeom prst="rect">
+            <a:avLst/>
+          </a:prstGeom>
+          <a:solidFill>
+            <a:srgbClr val="F4F5F7"/>
+          </a:solidFill>
+          <a:ln>
+            <a:noFill/>
+          </a:ln>
+          <a:effectLst/>
+        </p:spPr>
+        <p:style>
+          <a:lnRef idx="1">
+            <a:schemeClr val="accent1"/>
+          </a:lnRef>
+          <a:fillRef idx="3">
+            <a:schemeClr val="accent1"/>
+          </a:fillRef>
+          <a:effectRef idx="2">
+            <a:schemeClr val="accent1"/>
+          </a:effectRef>
+          <a:fontRef idx="minor">
+            <a:schemeClr val="lt1"/>
+          </a:fontRef>
+        </p:style>
+        <p:txBody>
+          <a:bodyPr rtlCol="0" anchor="ctr"/>
+          <a:lstStyle/>
+          <a:p>
+            <a:pPr algn="ctr"/>
+          </a:p>
+        </p:txBody>
+      </p:sp>
+      <p:sp>
+        <p:nvSpPr>
+          <p:cNvPr id="13" name="Rectangle 12"/>
+          <p:cNvSpPr/>
+          <p:nvPr/>
+        </p:nvSpPr>
+        <p:spPr>
+          <a:xfrm>
+            <a:off x="502920" y="2606040"/>
+            <a:ext cx="3657600" cy="45720"/>
+          </a:xfrm>
+          <a:prstGeom prst="rect">
+            <a:avLst/>
+          </a:prstGeom>
+          <a:solidFill>
+            <a:srgbClr val="B6142E"/>
+          </a:solidFill>
+          <a:ln>
+            <a:noFill/>
+          </a:ln>
+          <a:effectLst/>
+        </p:spPr>
+        <p:style>
+          <a:lnRef idx="1">
+            <a:schemeClr val="accent1"/>
+          </a:lnRef>
+          <a:fillRef idx="3">
+            <a:schemeClr val="accent1"/>
+          </a:fillRef>
+          <a:effectRef idx="2">
+            <a:schemeClr val="accent1"/>
+          </a:effectRef>
+          <a:fontRef idx="minor">
+            <a:schemeClr val="lt1"/>
+          </a:fontRef>
+        </p:style>
+        <p:txBody>
+          <a:bodyPr rtlCol="0" anchor="ctr"/>
+          <a:lstStyle/>
+          <a:p>
+            <a:pPr algn="ctr"/>
+          </a:p>
+        </p:txBody>
+      </p:sp>
+      <p:sp>
+        <p:nvSpPr>
+          <p:cNvPr id="14" name="TextBox 13"/>
+          <p:cNvSpPr txBox="1"/>
+          <p:nvPr/>
+        </p:nvSpPr>
+        <p:spPr>
+          <a:xfrm>
+            <a:off x="685800" y="2743200"/>
+            <a:ext cx="3383280" cy="320040"/>
+          </a:xfrm>
+          <a:prstGeom prst="rect">
+            <a:avLst/>
+          </a:prstGeom>
+          <a:noFill/>
+        </p:spPr>
+        <p:txBody>
+          <a:bodyPr wrap="square" anchor="t" lIns="0" rIns="0" tIns="0" bIns="0">
+            <a:spAutoFit/>
+          </a:bodyPr>
+          <a:lstStyle/>
+          <a:p>
+            <a:pPr algn="l">
+              <a:lnSpc>
+                <a:spcPct val="115000"/>
+              </a:lnSpc>
+            </a:pPr>
+            <a:r>
+              <a:rPr sz="1400" b="1" i="0">
+                <a:solidFill>
+                  <a:srgbClr val="1B1F29"/>
+                </a:solidFill>
+                <a:latin typeface="Helvetica Neue"/>
+              </a:rPr>
+              <a:t>Semiconductors</a:t>
+            </a:r>
+          </a:p>
+        </p:txBody>
+      </p:sp>
+      <p:sp>
+        <p:nvSpPr>
+          <p:cNvPr id="15" name="TextBox 14"/>
+          <p:cNvSpPr txBox="1"/>
+          <p:nvPr/>
+        </p:nvSpPr>
+        <p:spPr>
+          <a:xfrm>
+            <a:off x="685800" y="3063240"/>
+            <a:ext cx="3383280" cy="228600"/>
+          </a:xfrm>
+          <a:prstGeom prst="rect">
+            <a:avLst/>
+          </a:prstGeom>
+          <a:noFill/>
+        </p:spPr>
+        <p:txBody>
+          <a:bodyPr wrap="square" anchor="t" lIns="0" rIns="0" tIns="0" bIns="0">
+            <a:spAutoFit/>
+          </a:bodyPr>
+          <a:lstStyle/>
+          <a:p>
+            <a:pPr algn="l">
+              <a:lnSpc>
+                <a:spcPct val="115000"/>
+              </a:lnSpc>
+            </a:pPr>
+            <a:r>
+              <a:rPr sz="900" b="0" i="1">
+                <a:solidFill>
+                  <a:srgbClr val="555B6B"/>
+                </a:solidFill>
+                <a:latin typeface="Helvetica Neue"/>
+              </a:rPr>
+              <a:t>AI-era semis PE fund</a:t>
+            </a:r>
+          </a:p>
+        </p:txBody>
+      </p:sp>
+      <p:sp>
+        <p:nvSpPr>
+          <p:cNvPr id="16" name="TextBox 15"/>
+          <p:cNvSpPr txBox="1"/>
+          <p:nvPr/>
+        </p:nvSpPr>
+        <p:spPr>
+          <a:xfrm>
+            <a:off x="685800" y="3383280"/>
+            <a:ext cx="3291840" cy="1645920"/>
+          </a:xfrm>
+          <a:prstGeom prst="rect">
+            <a:avLst/>
+          </a:prstGeom>
+          <a:noFill/>
+        </p:spPr>
+        <p:txBody>
+          <a:bodyPr wrap="square" anchor="t" lIns="0" rIns="0" tIns="0" bIns="0">
+            <a:spAutoFit/>
+          </a:bodyPr>
+          <a:lstStyle/>
+          <a:p>
+            <a:pPr algn="l">
+              <a:lnSpc>
+                <a:spcPct val="115000"/>
+              </a:lnSpc>
+            </a:pPr>
+            <a:r>
+              <a:rPr sz="1000" b="0" i="0">
+                <a:solidFill>
+                  <a:srgbClr val="1B1F29"/>
+                </a:solidFill>
+                <a:latin typeface="Helvetica Neue"/>
+              </a:rPr>
               <a:t/>
             </a:r>
           </a:p>
           <a:p>
             <a:pPr algn="l">
               <a:lnSpc>
-                <a:spcPct val="130000"/>
+                <a:spcPct val="125000"/>
               </a:lnSpc>
               <a:spcBef>
-                <a:spcPts val="400"/>
+                <a:spcPts val="300"/>
               </a:spcBef>
               <a:buChar char="•"/>
               <a:buFont typeface="Helvetica Neue"/>
             </a:pPr>
             <a:r>
-              <a:rPr sz="1150" b="0" i="0">
+              <a:rPr sz="1000" b="0" i="0">
                 <a:solidFill>
                   <a:srgbClr val="1B1F29"/>
                 </a:solidFill>
                 <a:latin typeface="Helvetica Neue"/>
               </a:rPr>
-              <a:t>  Engineering depth in power electronics</a:t>
-            </a:r>
-          </a:p>
-          <a:p>
-            <a:pPr algn="l">
-              <a:lnSpc>
-                <a:spcPct val="130000"/>
+              <a:t>  GPU / AI accelerators — hyperscaler concentration</a:t>
+            </a:r>
+          </a:p>
+          <a:p>
+            <a:pPr algn="l">
+              <a:lnSpc>
+                <a:spcPct val="125000"/>
               </a:lnSpc>
               <a:spcBef>
-                <a:spcPts val="400"/>
+                <a:spcPts val="300"/>
               </a:spcBef>
               <a:buChar char="•"/>
               <a:buFont typeface="Helvetica Neue"/>
             </a:pPr>
             <a:r>
-              <a:rPr sz="1150" b="0" i="0">
+              <a:rPr sz="1000" b="0" i="0">
                 <a:solidFill>
                   <a:srgbClr val="1B1F29"/>
                 </a:solidFill>
                 <a:latin typeface="Helvetica Neue"/>
               </a:rPr>
-              <a:t>  Python + sensitivity-analysis fluency</a:t>
-            </a:r>
-          </a:p>
-          <a:p>
-            <a:pPr algn="l">
-              <a:lnSpc>
-                <a:spcPct val="130000"/>
+              <a:t>  ASIC specialists — per-customer design cycle</a:t>
+            </a:r>
+          </a:p>
+          <a:p>
+            <a:pPr algn="l">
+              <a:lnSpc>
+                <a:spcPct val="125000"/>
               </a:lnSpc>
               <a:spcBef>
-                <a:spcPts val="400"/>
+                <a:spcPts val="300"/>
               </a:spcBef>
               <a:buChar char="•"/>
               <a:buFont typeface="Helvetica Neue"/>
             </a:pPr>
             <a:r>
-              <a:rPr sz="1150" b="0" i="0">
+              <a:rPr sz="1000" b="0" i="0">
                 <a:solidFill>
                   <a:srgbClr val="1B1F29"/>
                 </a:solidFill>
                 <a:latin typeface="Helvetica Neue"/>
               </a:rPr>
-              <a:t>  Reflex for decomposing concentrated risk</a:t>
-            </a:r>
-          </a:p>
-          <a:p>
-            <a:pPr algn="l">
-              <a:lnSpc>
-                <a:spcPct val="130000"/>
+              <a:t>  Advanced packaging (CoWoS / HBM) — capacity premium</a:t>
+            </a:r>
+          </a:p>
+          <a:p>
+            <a:pPr algn="l">
+              <a:lnSpc>
+                <a:spcPct val="125000"/>
               </a:lnSpc>
               <a:spcBef>
-                <a:spcPts val="400"/>
+                <a:spcPts val="300"/>
               </a:spcBef>
               <a:buChar char="•"/>
               <a:buFont typeface="Helvetica Neue"/>
             </a:pPr>
             <a:r>
-              <a:rPr sz="1150" b="0" i="0">
+              <a:rPr sz="1000" b="0" i="0">
                 <a:solidFill>
                   <a:srgbClr val="1B1F29"/>
                 </a:solidFill>
                 <a:latin typeface="Helvetica Neue"/>
               </a:rPr>
-              <a:t>  Willingness to admit what I don't know</a:t>
-            </a:r>
-          </a:p>
-        </p:txBody>
-      </p:sp>
-      <p:sp>
-        <p:nvSpPr>
-          <p:cNvPr id="14" name="TextBox 13"/>
-          <p:cNvSpPr txBox="1"/>
-          <p:nvPr/>
-        </p:nvSpPr>
-        <p:spPr>
-          <a:xfrm>
-            <a:off x="7543800" y="4114800"/>
-            <a:ext cx="4114800" cy="320040"/>
-          </a:xfrm>
-          <a:prstGeom prst="rect">
-            <a:avLst/>
-          </a:prstGeom>
-          <a:noFill/>
-        </p:spPr>
-        <p:txBody>
-          <a:bodyPr wrap="square" anchor="t" lIns="0" rIns="0" tIns="0" bIns="0">
-            <a:spAutoFit/>
-          </a:bodyPr>
-          <a:lstStyle/>
-          <a:p>
-            <a:pPr algn="l">
-              <a:lnSpc>
-                <a:spcPct val="115000"/>
-              </a:lnSpc>
-            </a:pPr>
-            <a:r>
-              <a:rPr sz="1000" b="1" i="0">
-                <a:solidFill>
-                  <a:srgbClr val="A81B1B"/>
-                </a:solidFill>
-                <a:latin typeface="Helvetica Neue"/>
-              </a:rPr>
-              <a:t>WHAT I DON'T (YET)</a:t>
-            </a:r>
-          </a:p>
-        </p:txBody>
-      </p:sp>
-      <p:sp>
-        <p:nvSpPr>
-          <p:cNvPr id="15" name="TextBox 14"/>
-          <p:cNvSpPr txBox="1"/>
-          <p:nvPr/>
-        </p:nvSpPr>
-        <p:spPr>
-          <a:xfrm>
-            <a:off x="7543800" y="4434840"/>
-            <a:ext cx="4023360" cy="1463040"/>
-          </a:xfrm>
-          <a:prstGeom prst="rect">
-            <a:avLst/>
-          </a:prstGeom>
-          <a:noFill/>
-        </p:spPr>
-        <p:txBody>
-          <a:bodyPr wrap="square" anchor="t" lIns="0" rIns="0" tIns="0" bIns="0">
-            <a:spAutoFit/>
-          </a:bodyPr>
-          <a:lstStyle/>
-          <a:p>
-            <a:pPr algn="l">
-              <a:lnSpc>
-                <a:spcPct val="115000"/>
-              </a:lnSpc>
-            </a:pPr>
-            <a:r>
-              <a:rPr sz="1100" b="0" i="0">
-                <a:solidFill>
-                  <a:srgbClr val="1B1F29"/>
-                </a:solidFill>
-                <a:latin typeface="Helvetica Neue"/>
-              </a:rPr>
-              <a:t/>
-            </a:r>
-          </a:p>
-          <a:p>
-            <a:pPr algn="l">
-              <a:lnSpc>
-                <a:spcPct val="130000"/>
+              <a:t>  Lithography &amp; deposition (ASML, Applied, Lam) — oligopoly</a:t>
+            </a:r>
+          </a:p>
+          <a:p>
+            <a:pPr algn="l">
+              <a:lnSpc>
+                <a:spcPct val="125000"/>
               </a:lnSpc>
               <a:spcBef>
-                <a:spcPts val="400"/>
+                <a:spcPts val="300"/>
               </a:spcBef>
               <a:buChar char="•"/>
               <a:buFont typeface="Helvetica Neue"/>
             </a:pPr>
             <a:r>
-              <a:rPr sz="1150" b="0" i="0">
+              <a:rPr sz="1000" b="0" i="0">
                 <a:solidFill>
                   <a:srgbClr val="1B1F29"/>
                 </a:solidFill>
                 <a:latin typeface="Helvetica Neue"/>
               </a:rPr>
-              <a:t>  Transaction experience on NAV deals</a:t>
-            </a:r>
-          </a:p>
-          <a:p>
-            <a:pPr algn="l">
-              <a:lnSpc>
-                <a:spcPct val="130000"/>
+              <a:t>  Mature-node foundries — defensive baseline</a:t>
+            </a:r>
+          </a:p>
+        </p:txBody>
+      </p:sp>
+      <p:sp>
+        <p:nvSpPr>
+          <p:cNvPr id="17" name="TextBox 16"/>
+          <p:cNvSpPr txBox="1"/>
+          <p:nvPr/>
+        </p:nvSpPr>
+        <p:spPr>
+          <a:xfrm>
+            <a:off x="685800" y="5029200"/>
+            <a:ext cx="3383280" cy="182880"/>
+          </a:xfrm>
+          <a:prstGeom prst="rect">
+            <a:avLst/>
+          </a:prstGeom>
+          <a:noFill/>
+        </p:spPr>
+        <p:txBody>
+          <a:bodyPr wrap="square" anchor="t" lIns="0" rIns="0" tIns="0" bIns="0">
+            <a:spAutoFit/>
+          </a:bodyPr>
+          <a:lstStyle/>
+          <a:p>
+            <a:pPr algn="l">
+              <a:lnSpc>
+                <a:spcPct val="115000"/>
+              </a:lnSpc>
+            </a:pPr>
+            <a:r>
+              <a:rPr sz="800" b="1" i="0">
+                <a:solidFill>
+                  <a:srgbClr val="B6142E"/>
+                </a:solidFill>
+                <a:latin typeface="Helvetica Neue"/>
+              </a:rPr>
+              <a:t>STRESS DISPERSION FROM:</a:t>
+            </a:r>
+          </a:p>
+        </p:txBody>
+      </p:sp>
+      <p:sp>
+        <p:nvSpPr>
+          <p:cNvPr id="18" name="TextBox 17"/>
+          <p:cNvSpPr txBox="1"/>
+          <p:nvPr/>
+        </p:nvSpPr>
+        <p:spPr>
+          <a:xfrm>
+            <a:off x="685800" y="5212080"/>
+            <a:ext cx="3383280" cy="365760"/>
+          </a:xfrm>
+          <a:prstGeom prst="rect">
+            <a:avLst/>
+          </a:prstGeom>
+          <a:noFill/>
+        </p:spPr>
+        <p:txBody>
+          <a:bodyPr wrap="square" anchor="t" lIns="0" rIns="0" tIns="0" bIns="0">
+            <a:spAutoFit/>
+          </a:bodyPr>
+          <a:lstStyle/>
+          <a:p>
+            <a:pPr algn="l">
+              <a:lnSpc>
+                <a:spcPct val="125000"/>
+              </a:lnSpc>
+            </a:pPr>
+            <a:r>
+              <a:rPr sz="950" b="0" i="1">
+                <a:solidFill>
+                  <a:srgbClr val="1B1F29"/>
+                </a:solidFill>
+                <a:latin typeface="Helvetica Neue"/>
+              </a:rPr>
+              <a:t>Customer concentration × process-node × capex-cycle</a:t>
+            </a:r>
+          </a:p>
+        </p:txBody>
+      </p:sp>
+      <p:sp>
+        <p:nvSpPr>
+          <p:cNvPr id="19" name="Rectangle 18"/>
+          <p:cNvSpPr/>
+          <p:nvPr/>
+        </p:nvSpPr>
+        <p:spPr>
+          <a:xfrm>
+            <a:off x="4297680" y="2606040"/>
+            <a:ext cx="3657600" cy="3017520"/>
+          </a:xfrm>
+          <a:prstGeom prst="rect">
+            <a:avLst/>
+          </a:prstGeom>
+          <a:solidFill>
+            <a:srgbClr val="F4F5F7"/>
+          </a:solidFill>
+          <a:ln>
+            <a:noFill/>
+          </a:ln>
+          <a:effectLst/>
+        </p:spPr>
+        <p:style>
+          <a:lnRef idx="1">
+            <a:schemeClr val="accent1"/>
+          </a:lnRef>
+          <a:fillRef idx="3">
+            <a:schemeClr val="accent1"/>
+          </a:fillRef>
+          <a:effectRef idx="2">
+            <a:schemeClr val="accent1"/>
+          </a:effectRef>
+          <a:fontRef idx="minor">
+            <a:schemeClr val="lt1"/>
+          </a:fontRef>
+        </p:style>
+        <p:txBody>
+          <a:bodyPr rtlCol="0" anchor="ctr"/>
+          <a:lstStyle/>
+          <a:p>
+            <a:pPr algn="ctr"/>
+          </a:p>
+        </p:txBody>
+      </p:sp>
+      <p:sp>
+        <p:nvSpPr>
+          <p:cNvPr id="20" name="Rectangle 19"/>
+          <p:cNvSpPr/>
+          <p:nvPr/>
+        </p:nvSpPr>
+        <p:spPr>
+          <a:xfrm>
+            <a:off x="4297680" y="2606040"/>
+            <a:ext cx="3657600" cy="45720"/>
+          </a:xfrm>
+          <a:prstGeom prst="rect">
+            <a:avLst/>
+          </a:prstGeom>
+          <a:solidFill>
+            <a:srgbClr val="B6142E"/>
+          </a:solidFill>
+          <a:ln>
+            <a:noFill/>
+          </a:ln>
+          <a:effectLst/>
+        </p:spPr>
+        <p:style>
+          <a:lnRef idx="1">
+            <a:schemeClr val="accent1"/>
+          </a:lnRef>
+          <a:fillRef idx="3">
+            <a:schemeClr val="accent1"/>
+          </a:fillRef>
+          <a:effectRef idx="2">
+            <a:schemeClr val="accent1"/>
+          </a:effectRef>
+          <a:fontRef idx="minor">
+            <a:schemeClr val="lt1"/>
+          </a:fontRef>
+        </p:style>
+        <p:txBody>
+          <a:bodyPr rtlCol="0" anchor="ctr"/>
+          <a:lstStyle/>
+          <a:p>
+            <a:pPr algn="ctr"/>
+          </a:p>
+        </p:txBody>
+      </p:sp>
+      <p:sp>
+        <p:nvSpPr>
+          <p:cNvPr id="21" name="TextBox 20"/>
+          <p:cNvSpPr txBox="1"/>
+          <p:nvPr/>
+        </p:nvSpPr>
+        <p:spPr>
+          <a:xfrm>
+            <a:off x="4480560" y="2743200"/>
+            <a:ext cx="3383280" cy="320040"/>
+          </a:xfrm>
+          <a:prstGeom prst="rect">
+            <a:avLst/>
+          </a:prstGeom>
+          <a:noFill/>
+        </p:spPr>
+        <p:txBody>
+          <a:bodyPr wrap="square" anchor="t" lIns="0" rIns="0" tIns="0" bIns="0">
+            <a:spAutoFit/>
+          </a:bodyPr>
+          <a:lstStyle/>
+          <a:p>
+            <a:pPr algn="l">
+              <a:lnSpc>
+                <a:spcPct val="115000"/>
+              </a:lnSpc>
+            </a:pPr>
+            <a:r>
+              <a:rPr sz="1400" b="1" i="0">
+                <a:solidFill>
+                  <a:srgbClr val="1B1F29"/>
+                </a:solidFill>
+                <a:latin typeface="Helvetica Neue"/>
+              </a:rPr>
+              <a:t>Medical devices</a:t>
+            </a:r>
+          </a:p>
+        </p:txBody>
+      </p:sp>
+      <p:sp>
+        <p:nvSpPr>
+          <p:cNvPr id="22" name="TextBox 21"/>
+          <p:cNvSpPr txBox="1"/>
+          <p:nvPr/>
+        </p:nvSpPr>
+        <p:spPr>
+          <a:xfrm>
+            <a:off x="4480560" y="3063240"/>
+            <a:ext cx="3383280" cy="228600"/>
+          </a:xfrm>
+          <a:prstGeom prst="rect">
+            <a:avLst/>
+          </a:prstGeom>
+          <a:noFill/>
+        </p:spPr>
+        <p:txBody>
+          <a:bodyPr wrap="square" anchor="t" lIns="0" rIns="0" tIns="0" bIns="0">
+            <a:spAutoFit/>
+          </a:bodyPr>
+          <a:lstStyle/>
+          <a:p>
+            <a:pPr algn="l">
+              <a:lnSpc>
+                <a:spcPct val="115000"/>
+              </a:lnSpc>
+            </a:pPr>
+            <a:r>
+              <a:rPr sz="900" b="0" i="1">
+                <a:solidFill>
+                  <a:srgbClr val="555B6B"/>
+                </a:solidFill>
+                <a:latin typeface="Helvetica Neue"/>
+              </a:rPr>
+              <a:t>Surgical / interventional medtech PE</a:t>
+            </a:r>
+          </a:p>
+        </p:txBody>
+      </p:sp>
+      <p:sp>
+        <p:nvSpPr>
+          <p:cNvPr id="23" name="TextBox 22"/>
+          <p:cNvSpPr txBox="1"/>
+          <p:nvPr/>
+        </p:nvSpPr>
+        <p:spPr>
+          <a:xfrm>
+            <a:off x="4480560" y="3383280"/>
+            <a:ext cx="3291840" cy="1645920"/>
+          </a:xfrm>
+          <a:prstGeom prst="rect">
+            <a:avLst/>
+          </a:prstGeom>
+          <a:noFill/>
+        </p:spPr>
+        <p:txBody>
+          <a:bodyPr wrap="square" anchor="t" lIns="0" rIns="0" tIns="0" bIns="0">
+            <a:spAutoFit/>
+          </a:bodyPr>
+          <a:lstStyle/>
+          <a:p>
+            <a:pPr algn="l">
+              <a:lnSpc>
+                <a:spcPct val="115000"/>
+              </a:lnSpc>
+            </a:pPr>
+            <a:r>
+              <a:rPr sz="1000" b="0" i="0">
+                <a:solidFill>
+                  <a:srgbClr val="1B1F29"/>
+                </a:solidFill>
+                <a:latin typeface="Helvetica Neue"/>
+              </a:rPr>
+              <a:t/>
+            </a:r>
+          </a:p>
+          <a:p>
+            <a:pPr algn="l">
+              <a:lnSpc>
+                <a:spcPct val="125000"/>
               </a:lnSpc>
               <a:spcBef>
-                <a:spcPts val="400"/>
+                <a:spcPts val="300"/>
               </a:spcBef>
               <a:buChar char="•"/>
               <a:buFont typeface="Helvetica Neue"/>
             </a:pPr>
             <a:r>
-              <a:rPr sz="1150" b="0" i="0">
+              <a:rPr sz="1000" b="0" i="0">
                 <a:solidFill>
                   <a:srgbClr val="1B1F29"/>
                 </a:solidFill>
                 <a:latin typeface="Helvetica Neue"/>
               </a:rPr>
-              <a:t>  Legal / credit-document grammar</a:t>
-            </a:r>
-          </a:p>
-          <a:p>
-            <a:pPr algn="l">
-              <a:lnSpc>
-                <a:spcPct val="130000"/>
+              <a:t>  Surgical robotics — 7–10y replacement cycles</a:t>
+            </a:r>
+          </a:p>
+          <a:p>
+            <a:pPr algn="l">
+              <a:lnSpc>
+                <a:spcPct val="125000"/>
               </a:lnSpc>
               <a:spcBef>
-                <a:spcPts val="400"/>
+                <a:spcPts val="300"/>
               </a:spcBef>
               <a:buChar char="•"/>
               <a:buFont typeface="Helvetica Neue"/>
             </a:pPr>
             <a:r>
-              <a:rPr sz="1150" b="0" i="0">
+              <a:rPr sz="1000" b="0" i="0">
                 <a:solidFill>
                   <a:srgbClr val="1B1F29"/>
                 </a:solidFill>
                 <a:latin typeface="Helvetica Neue"/>
               </a:rPr>
-              <a:t>  Workout mechanics of facility breaches</a:t>
-            </a:r>
-          </a:p>
-          <a:p>
-            <a:pPr algn="l">
-              <a:lnSpc>
-                <a:spcPct val="130000"/>
+              <a:t>  Disposables &amp; instruments — recurring, GMP moat</a:t>
+            </a:r>
+          </a:p>
+          <a:p>
+            <a:pPr algn="l">
+              <a:lnSpc>
+                <a:spcPct val="125000"/>
               </a:lnSpc>
               <a:spcBef>
-                <a:spcPts val="400"/>
+                <a:spcPts val="300"/>
               </a:spcBef>
               <a:buChar char="•"/>
               <a:buFont typeface="Helvetica Neue"/>
             </a:pPr>
             <a:r>
-              <a:rPr sz="1150" b="0" i="0">
+              <a:rPr sz="1000" b="0" i="0">
                 <a:solidFill>
                   <a:srgbClr val="1B1F29"/>
                 </a:solidFill>
                 <a:latin typeface="Helvetica Neue"/>
               </a:rPr>
-              <a:t>  Desk-level pricing conventions</a:t>
+              <a:t>  Digital surgery / workflow software — SaaS-like</a:t>
+            </a:r>
+          </a:p>
+          <a:p>
+            <a:pPr algn="l">
+              <a:lnSpc>
+                <a:spcPct val="125000"/>
+              </a:lnSpc>
+              <a:spcBef>
+                <a:spcPts val="300"/>
+              </a:spcBef>
+              <a:buChar char="•"/>
+              <a:buFont typeface="Helvetica Neue"/>
+            </a:pPr>
+            <a:r>
+              <a:rPr sz="1000" b="0" i="0">
+                <a:solidFill>
+                  <a:srgbClr val="1B1F29"/>
+                </a:solidFill>
+                <a:latin typeface="Helvetica Neue"/>
+              </a:rPr>
+              <a:t>  Interventional cardiology — FDA-pipeline timing</a:t>
+            </a:r>
+          </a:p>
+          <a:p>
+            <a:pPr algn="l">
+              <a:lnSpc>
+                <a:spcPct val="125000"/>
+              </a:lnSpc>
+              <a:spcBef>
+                <a:spcPts val="300"/>
+              </a:spcBef>
+              <a:buChar char="•"/>
+              <a:buFont typeface="Helvetica Neue"/>
+            </a:pPr>
+            <a:r>
+              <a:rPr sz="1000" b="0" i="0">
+                <a:solidFill>
+                  <a:srgbClr val="1B1F29"/>
+                </a:solidFill>
+                <a:latin typeface="Helvetica Neue"/>
+              </a:rPr>
+              <a:t>  Diagnostic imaging — reimbursement-code dynamics</a:t>
+            </a:r>
+          </a:p>
+        </p:txBody>
+      </p:sp>
+      <p:sp>
+        <p:nvSpPr>
+          <p:cNvPr id="24" name="TextBox 23"/>
+          <p:cNvSpPr txBox="1"/>
+          <p:nvPr/>
+        </p:nvSpPr>
+        <p:spPr>
+          <a:xfrm>
+            <a:off x="4480560" y="5029200"/>
+            <a:ext cx="3383280" cy="182880"/>
+          </a:xfrm>
+          <a:prstGeom prst="rect">
+            <a:avLst/>
+          </a:prstGeom>
+          <a:noFill/>
+        </p:spPr>
+        <p:txBody>
+          <a:bodyPr wrap="square" anchor="t" lIns="0" rIns="0" tIns="0" bIns="0">
+            <a:spAutoFit/>
+          </a:bodyPr>
+          <a:lstStyle/>
+          <a:p>
+            <a:pPr algn="l">
+              <a:lnSpc>
+                <a:spcPct val="115000"/>
+              </a:lnSpc>
+            </a:pPr>
+            <a:r>
+              <a:rPr sz="800" b="1" i="0">
+                <a:solidFill>
+                  <a:srgbClr val="B6142E"/>
+                </a:solidFill>
+                <a:latin typeface="Helvetica Neue"/>
+              </a:rPr>
+              <a:t>STRESS DISPERSION FROM:</a:t>
+            </a:r>
+          </a:p>
+        </p:txBody>
+      </p:sp>
+      <p:sp>
+        <p:nvSpPr>
+          <p:cNvPr id="25" name="TextBox 24"/>
+          <p:cNvSpPr txBox="1"/>
+          <p:nvPr/>
+        </p:nvSpPr>
+        <p:spPr>
+          <a:xfrm>
+            <a:off x="4480560" y="5212080"/>
+            <a:ext cx="3383280" cy="365760"/>
+          </a:xfrm>
+          <a:prstGeom prst="rect">
+            <a:avLst/>
+          </a:prstGeom>
+          <a:noFill/>
+        </p:spPr>
+        <p:txBody>
+          <a:bodyPr wrap="square" anchor="t" lIns="0" rIns="0" tIns="0" bIns="0">
+            <a:spAutoFit/>
+          </a:bodyPr>
+          <a:lstStyle/>
+          <a:p>
+            <a:pPr algn="l">
+              <a:lnSpc>
+                <a:spcPct val="125000"/>
+              </a:lnSpc>
+            </a:pPr>
+            <a:r>
+              <a:rPr sz="950" b="0" i="1">
+                <a:solidFill>
+                  <a:srgbClr val="1B1F29"/>
+                </a:solidFill>
+                <a:latin typeface="Helvetica Neue"/>
+              </a:rPr>
+              <a:t>FDA timing × hospital capex × reimbursement codes</a:t>
+            </a:r>
+          </a:p>
+        </p:txBody>
+      </p:sp>
+      <p:sp>
+        <p:nvSpPr>
+          <p:cNvPr id="26" name="Rectangle 25"/>
+          <p:cNvSpPr/>
+          <p:nvPr/>
+        </p:nvSpPr>
+        <p:spPr>
+          <a:xfrm>
+            <a:off x="8092440" y="2606040"/>
+            <a:ext cx="3657600" cy="3017520"/>
+          </a:xfrm>
+          <a:prstGeom prst="rect">
+            <a:avLst/>
+          </a:prstGeom>
+          <a:solidFill>
+            <a:srgbClr val="F4F5F7"/>
+          </a:solidFill>
+          <a:ln>
+            <a:noFill/>
+          </a:ln>
+          <a:effectLst/>
+        </p:spPr>
+        <p:style>
+          <a:lnRef idx="1">
+            <a:schemeClr val="accent1"/>
+          </a:lnRef>
+          <a:fillRef idx="3">
+            <a:schemeClr val="accent1"/>
+          </a:fillRef>
+          <a:effectRef idx="2">
+            <a:schemeClr val="accent1"/>
+          </a:effectRef>
+          <a:fontRef idx="minor">
+            <a:schemeClr val="lt1"/>
+          </a:fontRef>
+        </p:style>
+        <p:txBody>
+          <a:bodyPr rtlCol="0" anchor="ctr"/>
+          <a:lstStyle/>
+          <a:p>
+            <a:pPr algn="ctr"/>
+          </a:p>
+        </p:txBody>
+      </p:sp>
+      <p:sp>
+        <p:nvSpPr>
+          <p:cNvPr id="27" name="Rectangle 26"/>
+          <p:cNvSpPr/>
+          <p:nvPr/>
+        </p:nvSpPr>
+        <p:spPr>
+          <a:xfrm>
+            <a:off x="8092440" y="2606040"/>
+            <a:ext cx="3657600" cy="45720"/>
+          </a:xfrm>
+          <a:prstGeom prst="rect">
+            <a:avLst/>
+          </a:prstGeom>
+          <a:solidFill>
+            <a:srgbClr val="B6142E"/>
+          </a:solidFill>
+          <a:ln>
+            <a:noFill/>
+          </a:ln>
+          <a:effectLst/>
+        </p:spPr>
+        <p:style>
+          <a:lnRef idx="1">
+            <a:schemeClr val="accent1"/>
+          </a:lnRef>
+          <a:fillRef idx="3">
+            <a:schemeClr val="accent1"/>
+          </a:fillRef>
+          <a:effectRef idx="2">
+            <a:schemeClr val="accent1"/>
+          </a:effectRef>
+          <a:fontRef idx="minor">
+            <a:schemeClr val="lt1"/>
+          </a:fontRef>
+        </p:style>
+        <p:txBody>
+          <a:bodyPr rtlCol="0" anchor="ctr"/>
+          <a:lstStyle/>
+          <a:p>
+            <a:pPr algn="ctr"/>
+          </a:p>
+        </p:txBody>
+      </p:sp>
+      <p:sp>
+        <p:nvSpPr>
+          <p:cNvPr id="28" name="TextBox 27"/>
+          <p:cNvSpPr txBox="1"/>
+          <p:nvPr/>
+        </p:nvSpPr>
+        <p:spPr>
+          <a:xfrm>
+            <a:off x="8275320" y="2743200"/>
+            <a:ext cx="3383280" cy="320040"/>
+          </a:xfrm>
+          <a:prstGeom prst="rect">
+            <a:avLst/>
+          </a:prstGeom>
+          <a:noFill/>
+        </p:spPr>
+        <p:txBody>
+          <a:bodyPr wrap="square" anchor="t" lIns="0" rIns="0" tIns="0" bIns="0">
+            <a:spAutoFit/>
+          </a:bodyPr>
+          <a:lstStyle/>
+          <a:p>
+            <a:pPr algn="l">
+              <a:lnSpc>
+                <a:spcPct val="115000"/>
+              </a:lnSpc>
+            </a:pPr>
+            <a:r>
+              <a:rPr sz="1400" b="1" i="0">
+                <a:solidFill>
+                  <a:srgbClr val="1B1F29"/>
+                </a:solidFill>
+                <a:latin typeface="Helvetica Neue"/>
+              </a:rPr>
+              <a:t>Grid modernisation</a:t>
+            </a:r>
+          </a:p>
+        </p:txBody>
+      </p:sp>
+      <p:sp>
+        <p:nvSpPr>
+          <p:cNvPr id="29" name="TextBox 28"/>
+          <p:cNvSpPr txBox="1"/>
+          <p:nvPr/>
+        </p:nvSpPr>
+        <p:spPr>
+          <a:xfrm>
+            <a:off x="8275320" y="3063240"/>
+            <a:ext cx="3383280" cy="228600"/>
+          </a:xfrm>
+          <a:prstGeom prst="rect">
+            <a:avLst/>
+          </a:prstGeom>
+          <a:noFill/>
+        </p:spPr>
+        <p:txBody>
+          <a:bodyPr wrap="square" anchor="t" lIns="0" rIns="0" tIns="0" bIns="0">
+            <a:spAutoFit/>
+          </a:bodyPr>
+          <a:lstStyle/>
+          <a:p>
+            <a:pPr algn="l">
+              <a:lnSpc>
+                <a:spcPct val="115000"/>
+              </a:lnSpc>
+            </a:pPr>
+            <a:r>
+              <a:rPr sz="900" b="0" i="1">
+                <a:solidFill>
+                  <a:srgbClr val="555B6B"/>
+                </a:solidFill>
+                <a:latin typeface="Helvetica Neue"/>
+              </a:rPr>
+              <a:t>T&amp;D / electrification PE fund</a:t>
+            </a:r>
+          </a:p>
+        </p:txBody>
+      </p:sp>
+      <p:sp>
+        <p:nvSpPr>
+          <p:cNvPr id="30" name="TextBox 29"/>
+          <p:cNvSpPr txBox="1"/>
+          <p:nvPr/>
+        </p:nvSpPr>
+        <p:spPr>
+          <a:xfrm>
+            <a:off x="8275320" y="3383280"/>
+            <a:ext cx="3291840" cy="1645920"/>
+          </a:xfrm>
+          <a:prstGeom prst="rect">
+            <a:avLst/>
+          </a:prstGeom>
+          <a:noFill/>
+        </p:spPr>
+        <p:txBody>
+          <a:bodyPr wrap="square" anchor="t" lIns="0" rIns="0" tIns="0" bIns="0">
+            <a:spAutoFit/>
+          </a:bodyPr>
+          <a:lstStyle/>
+          <a:p>
+            <a:pPr algn="l">
+              <a:lnSpc>
+                <a:spcPct val="115000"/>
+              </a:lnSpc>
+            </a:pPr>
+            <a:r>
+              <a:rPr sz="1000" b="0" i="0">
+                <a:solidFill>
+                  <a:srgbClr val="1B1F29"/>
+                </a:solidFill>
+                <a:latin typeface="Helvetica Neue"/>
+              </a:rPr>
+              <a:t/>
+            </a:r>
+          </a:p>
+          <a:p>
+            <a:pPr algn="l">
+              <a:lnSpc>
+                <a:spcPct val="125000"/>
+              </a:lnSpc>
+              <a:spcBef>
+                <a:spcPts val="300"/>
+              </a:spcBef>
+              <a:buChar char="•"/>
+              <a:buFont typeface="Helvetica Neue"/>
+            </a:pPr>
+            <a:r>
+              <a:rPr sz="1000" b="0" i="0">
+                <a:solidFill>
+                  <a:srgbClr val="1B1F29"/>
+                </a:solidFill>
+                <a:latin typeface="Helvetica Neue"/>
+              </a:rPr>
+              <a:t>  T&amp;D equipment — 2–4y lead-time crisis premium</a:t>
+            </a:r>
+          </a:p>
+          <a:p>
+            <a:pPr algn="l">
+              <a:lnSpc>
+                <a:spcPct val="125000"/>
+              </a:lnSpc>
+              <a:spcBef>
+                <a:spcPts val="300"/>
+              </a:spcBef>
+              <a:buChar char="•"/>
+              <a:buFont typeface="Helvetica Neue"/>
+            </a:pPr>
+            <a:r>
+              <a:rPr sz="1000" b="0" i="0">
+                <a:solidFill>
+                  <a:srgbClr val="1B1F29"/>
+                </a:solidFill>
+                <a:latin typeface="Helvetica Neue"/>
+              </a:rPr>
+              <a:t>  Grid-scale storage integrators — queue-dependent</a:t>
+            </a:r>
+          </a:p>
+          <a:p>
+            <a:pPr algn="l">
+              <a:lnSpc>
+                <a:spcPct val="125000"/>
+              </a:lnSpc>
+              <a:spcBef>
+                <a:spcPts val="300"/>
+              </a:spcBef>
+              <a:buChar char="•"/>
+              <a:buFont typeface="Helvetica Neue"/>
+            </a:pPr>
+            <a:r>
+              <a:rPr sz="1000" b="0" i="0">
+                <a:solidFill>
+                  <a:srgbClr val="1B1F29"/>
+                </a:solidFill>
+                <a:latin typeface="Helvetica Neue"/>
+              </a:rPr>
+              <a:t>  DERMS / utility software — recurring + integration</a:t>
+            </a:r>
+          </a:p>
+          <a:p>
+            <a:pPr algn="l">
+              <a:lnSpc>
+                <a:spcPct val="125000"/>
+              </a:lnSpc>
+              <a:spcBef>
+                <a:spcPts val="300"/>
+              </a:spcBef>
+              <a:buChar char="•"/>
+              <a:buFont typeface="Helvetica Neue"/>
+            </a:pPr>
+            <a:r>
+              <a:rPr sz="1000" b="0" i="0">
+                <a:solidFill>
+                  <a:srgbClr val="1B1F29"/>
+                </a:solidFill>
+                <a:latin typeface="Helvetica Neue"/>
+              </a:rPr>
+              <a:t>  EV charging infrastructure — utilisation × policy</a:t>
+            </a:r>
+          </a:p>
+          <a:p>
+            <a:pPr algn="l">
+              <a:lnSpc>
+                <a:spcPct val="125000"/>
+              </a:lnSpc>
+              <a:spcBef>
+                <a:spcPts val="300"/>
+              </a:spcBef>
+              <a:buChar char="•"/>
+              <a:buFont typeface="Helvetica Neue"/>
+            </a:pPr>
+            <a:r>
+              <a:rPr sz="1000" b="0" i="0">
+                <a:solidFill>
+                  <a:srgbClr val="1B1F29"/>
+                </a:solidFill>
+                <a:latin typeface="Helvetica Neue"/>
+              </a:rPr>
+              <a:t>  Interconnection / EPC services — queue management</a:t>
+            </a:r>
+          </a:p>
+        </p:txBody>
+      </p:sp>
+      <p:sp>
+        <p:nvSpPr>
+          <p:cNvPr id="31" name="TextBox 30"/>
+          <p:cNvSpPr txBox="1"/>
+          <p:nvPr/>
+        </p:nvSpPr>
+        <p:spPr>
+          <a:xfrm>
+            <a:off x="8275320" y="5029200"/>
+            <a:ext cx="3383280" cy="182880"/>
+          </a:xfrm>
+          <a:prstGeom prst="rect">
+            <a:avLst/>
+          </a:prstGeom>
+          <a:noFill/>
+        </p:spPr>
+        <p:txBody>
+          <a:bodyPr wrap="square" anchor="t" lIns="0" rIns="0" tIns="0" bIns="0">
+            <a:spAutoFit/>
+          </a:bodyPr>
+          <a:lstStyle/>
+          <a:p>
+            <a:pPr algn="l">
+              <a:lnSpc>
+                <a:spcPct val="115000"/>
+              </a:lnSpc>
+            </a:pPr>
+            <a:r>
+              <a:rPr sz="800" b="1" i="0">
+                <a:solidFill>
+                  <a:srgbClr val="B6142E"/>
+                </a:solidFill>
+                <a:latin typeface="Helvetica Neue"/>
+              </a:rPr>
+              <a:t>STRESS DISPERSION FROM:</a:t>
+            </a:r>
+          </a:p>
+        </p:txBody>
+      </p:sp>
+      <p:sp>
+        <p:nvSpPr>
+          <p:cNvPr id="32" name="TextBox 31"/>
+          <p:cNvSpPr txBox="1"/>
+          <p:nvPr/>
+        </p:nvSpPr>
+        <p:spPr>
+          <a:xfrm>
+            <a:off x="8275320" y="5212080"/>
+            <a:ext cx="3383280" cy="365760"/>
+          </a:xfrm>
+          <a:prstGeom prst="rect">
+            <a:avLst/>
+          </a:prstGeom>
+          <a:noFill/>
+        </p:spPr>
+        <p:txBody>
+          <a:bodyPr wrap="square" anchor="t" lIns="0" rIns="0" tIns="0" bIns="0">
+            <a:spAutoFit/>
+          </a:bodyPr>
+          <a:lstStyle/>
+          <a:p>
+            <a:pPr algn="l">
+              <a:lnSpc>
+                <a:spcPct val="125000"/>
+              </a:lnSpc>
+            </a:pPr>
+            <a:r>
+              <a:rPr sz="950" b="0" i="1">
+                <a:solidFill>
+                  <a:srgbClr val="1B1F29"/>
+                </a:solidFill>
+                <a:latin typeface="Helvetica Neue"/>
+              </a:rPr>
+              <a:t>Utility capex × policy × queue length × lead-time</a:t>
+            </a:r>
+          </a:p>
+        </p:txBody>
+      </p:sp>
+      <p:sp>
+        <p:nvSpPr>
+          <p:cNvPr id="33" name="Rectangle 32"/>
+          <p:cNvSpPr/>
+          <p:nvPr/>
+        </p:nvSpPr>
+        <p:spPr>
+          <a:xfrm>
+            <a:off x="502920" y="5852160"/>
+            <a:ext cx="11155680" cy="502920"/>
+          </a:xfrm>
+          <a:prstGeom prst="rect">
+            <a:avLst/>
+          </a:prstGeom>
+          <a:solidFill>
+            <a:srgbClr val="1B1F29"/>
+          </a:solidFill>
+          <a:ln>
+            <a:noFill/>
+          </a:ln>
+          <a:effectLst/>
+        </p:spPr>
+        <p:style>
+          <a:lnRef idx="1">
+            <a:schemeClr val="accent1"/>
+          </a:lnRef>
+          <a:fillRef idx="3">
+            <a:schemeClr val="accent1"/>
+          </a:fillRef>
+          <a:effectRef idx="2">
+            <a:schemeClr val="accent1"/>
+          </a:effectRef>
+          <a:fontRef idx="minor">
+            <a:schemeClr val="lt1"/>
+          </a:fontRef>
+        </p:style>
+        <p:txBody>
+          <a:bodyPr rtlCol="0" anchor="ctr"/>
+          <a:lstStyle/>
+          <a:p>
+            <a:pPr algn="ctr"/>
+          </a:p>
+        </p:txBody>
+      </p:sp>
+      <p:sp>
+        <p:nvSpPr>
+          <p:cNvPr id="34" name="TextBox 33"/>
+          <p:cNvSpPr txBox="1"/>
+          <p:nvPr/>
+        </p:nvSpPr>
+        <p:spPr>
+          <a:xfrm>
+            <a:off x="777240" y="5943600"/>
+            <a:ext cx="10607040" cy="365760"/>
+          </a:xfrm>
+          <a:prstGeom prst="rect">
+            <a:avLst/>
+          </a:prstGeom>
+          <a:noFill/>
+        </p:spPr>
+        <p:txBody>
+          <a:bodyPr wrap="square" anchor="t" lIns="0" rIns="0" tIns="0" bIns="0">
+            <a:spAutoFit/>
+          </a:bodyPr>
+          <a:lstStyle/>
+          <a:p>
+            <a:pPr algn="l">
+              <a:lnSpc>
+                <a:spcPct val="130000"/>
+              </a:lnSpc>
+            </a:pPr>
+            <a:r>
+              <a:rPr sz="1100" b="0" i="1">
+                <a:solidFill>
+                  <a:srgbClr val="FFFFFF"/>
+                </a:solidFill>
+                <a:latin typeface="Helvetica Neue"/>
+              </a:rPr>
+              <a:t>I can sketch the framework — calibrating any of these to covenant-relevant numbers needs the desk's private NAV marks. The reflex is the asset; calibration is the conversation.</a:t>
             </a:r>
           </a:p>
         </p:txBody>
@@ -5052,6 +5919,797 @@
         <p:spPr>
           <a:xfrm>
             <a:off x="0" y="0"/>
+            <a:ext cx="12191695" cy="137160"/>
+          </a:xfrm>
+          <a:prstGeom prst="rect">
+            <a:avLst/>
+          </a:prstGeom>
+          <a:solidFill>
+            <a:srgbClr val="B6142E"/>
+          </a:solidFill>
+          <a:ln>
+            <a:noFill/>
+          </a:ln>
+          <a:effectLst/>
+        </p:spPr>
+        <p:style>
+          <a:lnRef idx="1">
+            <a:schemeClr val="accent1"/>
+          </a:lnRef>
+          <a:fillRef idx="3">
+            <a:schemeClr val="accent1"/>
+          </a:fillRef>
+          <a:effectRef idx="2">
+            <a:schemeClr val="accent1"/>
+          </a:effectRef>
+          <a:fontRef idx="minor">
+            <a:schemeClr val="lt1"/>
+          </a:fontRef>
+        </p:style>
+        <p:txBody>
+          <a:bodyPr rtlCol="0" anchor="ctr"/>
+          <a:lstStyle/>
+          <a:p>
+            <a:pPr algn="ctr"/>
+          </a:p>
+        </p:txBody>
+      </p:sp>
+      <p:sp>
+        <p:nvSpPr>
+          <p:cNvPr id="3" name="TextBox 2"/>
+          <p:cNvSpPr txBox="1"/>
+          <p:nvPr/>
+        </p:nvSpPr>
+        <p:spPr>
+          <a:xfrm>
+            <a:off x="502920" y="365760"/>
+            <a:ext cx="10972800" cy="274320"/>
+          </a:xfrm>
+          <a:prstGeom prst="rect">
+            <a:avLst/>
+          </a:prstGeom>
+          <a:noFill/>
+        </p:spPr>
+        <p:txBody>
+          <a:bodyPr wrap="square" anchor="t" lIns="0" rIns="0" tIns="0" bIns="0">
+            <a:spAutoFit/>
+          </a:bodyPr>
+          <a:lstStyle/>
+          <a:p>
+            <a:pPr algn="l">
+              <a:lnSpc>
+                <a:spcPct val="115000"/>
+              </a:lnSpc>
+            </a:pPr>
+            <a:r>
+              <a:rPr sz="1000" b="1" i="0">
+                <a:solidFill>
+                  <a:srgbClr val="B6142E"/>
+                </a:solidFill>
+                <a:latin typeface="Helvetica Neue"/>
+              </a:rPr>
+              <a:t>10  ·  ABOUT ME</a:t>
+            </a:r>
+          </a:p>
+        </p:txBody>
+      </p:sp>
+      <p:sp>
+        <p:nvSpPr>
+          <p:cNvPr id="4" name="TextBox 3"/>
+          <p:cNvSpPr txBox="1"/>
+          <p:nvPr/>
+        </p:nvSpPr>
+        <p:spPr>
+          <a:xfrm>
+            <a:off x="502920" y="640080"/>
+            <a:ext cx="11155680" cy="685800"/>
+          </a:xfrm>
+          <a:prstGeom prst="rect">
+            <a:avLst/>
+          </a:prstGeom>
+          <a:noFill/>
+        </p:spPr>
+        <p:txBody>
+          <a:bodyPr wrap="square" anchor="t" lIns="0" rIns="0" tIns="0" bIns="0">
+            <a:spAutoFit/>
+          </a:bodyPr>
+          <a:lstStyle/>
+          <a:p>
+            <a:pPr algn="l">
+              <a:lnSpc>
+                <a:spcPct val="115000"/>
+              </a:lnSpc>
+            </a:pPr>
+            <a:r>
+              <a:rPr sz="2400" b="1" i="0">
+                <a:solidFill>
+                  <a:srgbClr val="1B1F29"/>
+                </a:solidFill>
+                <a:latin typeface="Helvetica Neue"/>
+              </a:rPr>
+              <a:t>An engineer applying to a non-engineering seat</a:t>
+            </a:r>
+          </a:p>
+        </p:txBody>
+      </p:sp>
+      <p:cxnSp>
+        <p:nvCxnSpPr>
+          <p:cNvPr id="5" name="Connector 4"/>
+          <p:cNvCxnSpPr/>
+          <p:nvPr/>
+        </p:nvCxnSpPr>
+        <p:spPr>
+          <a:xfrm>
+            <a:off x="502920" y="1298448"/>
+            <a:ext cx="11183112" cy="0"/>
+          </a:xfrm>
+          <a:prstGeom prst="line">
+            <a:avLst/>
+          </a:prstGeom>
+          <a:ln w="6350">
+            <a:solidFill>
+              <a:srgbClr val="C9CDD6"/>
+            </a:solidFill>
+          </a:ln>
+        </p:spPr>
+        <p:style>
+          <a:lnRef idx="2">
+            <a:schemeClr val="accent1"/>
+          </a:lnRef>
+          <a:fillRef idx="0">
+            <a:schemeClr val="accent1"/>
+          </a:fillRef>
+          <a:effectRef idx="1">
+            <a:schemeClr val="accent1"/>
+          </a:effectRef>
+          <a:fontRef idx="minor">
+            <a:schemeClr val="tx1"/>
+          </a:fontRef>
+        </p:style>
+      </p:cxnSp>
+      <p:cxnSp>
+        <p:nvCxnSpPr>
+          <p:cNvPr id="6" name="Connector 5"/>
+          <p:cNvCxnSpPr/>
+          <p:nvPr/>
+        </p:nvCxnSpPr>
+        <p:spPr>
+          <a:xfrm>
+            <a:off x="502920" y="6492240"/>
+            <a:ext cx="11183112" cy="0"/>
+          </a:xfrm>
+          <a:prstGeom prst="line">
+            <a:avLst/>
+          </a:prstGeom>
+          <a:ln w="6350">
+            <a:solidFill>
+              <a:srgbClr val="C9CDD6"/>
+            </a:solidFill>
+          </a:ln>
+        </p:spPr>
+        <p:style>
+          <a:lnRef idx="2">
+            <a:schemeClr val="accent1"/>
+          </a:lnRef>
+          <a:fillRef idx="0">
+            <a:schemeClr val="accent1"/>
+          </a:fillRef>
+          <a:effectRef idx="1">
+            <a:schemeClr val="accent1"/>
+          </a:effectRef>
+          <a:fontRef idx="minor">
+            <a:schemeClr val="tx1"/>
+          </a:fontRef>
+        </p:style>
+      </p:cxnSp>
+      <p:sp>
+        <p:nvSpPr>
+          <p:cNvPr id="7" name="TextBox 6"/>
+          <p:cNvSpPr txBox="1"/>
+          <p:nvPr/>
+        </p:nvSpPr>
+        <p:spPr>
+          <a:xfrm>
+            <a:off x="502920" y="6565392"/>
+            <a:ext cx="9144000" cy="274320"/>
+          </a:xfrm>
+          <a:prstGeom prst="rect">
+            <a:avLst/>
+          </a:prstGeom>
+          <a:noFill/>
+        </p:spPr>
+        <p:txBody>
+          <a:bodyPr wrap="square" anchor="t" lIns="0" rIns="0" tIns="0" bIns="0">
+            <a:spAutoFit/>
+          </a:bodyPr>
+          <a:lstStyle/>
+          <a:p>
+            <a:pPr algn="l">
+              <a:lnSpc>
+                <a:spcPct val="115000"/>
+              </a:lnSpc>
+            </a:pPr>
+            <a:r>
+              <a:rPr sz="900" b="0" i="0">
+                <a:solidFill>
+                  <a:srgbClr val="555B6B"/>
+                </a:solidFill>
+                <a:latin typeface="Helvetica Neue"/>
+              </a:rPr>
+              <a:t>UniCredit Fund Financing  ·  First Look  ·  Jiawen Cc  ·  Polimi EE M.Sc.  ·  June 2026</a:t>
+            </a:r>
+          </a:p>
+        </p:txBody>
+      </p:sp>
+      <p:sp>
+        <p:nvSpPr>
+          <p:cNvPr id="8" name="TextBox 7"/>
+          <p:cNvSpPr txBox="1"/>
+          <p:nvPr/>
+        </p:nvSpPr>
+        <p:spPr>
+          <a:xfrm>
+            <a:off x="10515600" y="6565392"/>
+            <a:ext cx="1188720" cy="274320"/>
+          </a:xfrm>
+          <a:prstGeom prst="rect">
+            <a:avLst/>
+          </a:prstGeom>
+          <a:noFill/>
+        </p:spPr>
+        <p:txBody>
+          <a:bodyPr wrap="square" anchor="t" lIns="0" rIns="0" tIns="0" bIns="0">
+            <a:spAutoFit/>
+          </a:bodyPr>
+          <a:lstStyle/>
+          <a:p>
+            <a:pPr algn="r">
+              <a:lnSpc>
+                <a:spcPct val="115000"/>
+              </a:lnSpc>
+            </a:pPr>
+            <a:r>
+              <a:rPr sz="900" b="0" i="0">
+                <a:solidFill>
+                  <a:srgbClr val="555B6B"/>
+                </a:solidFill>
+                <a:latin typeface="Helvetica Neue"/>
+              </a:rPr>
+              <a:t>12 / 13</a:t>
+            </a:r>
+          </a:p>
+        </p:txBody>
+      </p:sp>
+      <p:sp>
+        <p:nvSpPr>
+          <p:cNvPr id="9" name="TextBox 8"/>
+          <p:cNvSpPr txBox="1"/>
+          <p:nvPr/>
+        </p:nvSpPr>
+        <p:spPr>
+          <a:xfrm>
+            <a:off x="502920" y="1783080"/>
+            <a:ext cx="6400800" cy="365760"/>
+          </a:xfrm>
+          <a:prstGeom prst="rect">
+            <a:avLst/>
+          </a:prstGeom>
+          <a:noFill/>
+        </p:spPr>
+        <p:txBody>
+          <a:bodyPr wrap="square" anchor="t" lIns="0" rIns="0" tIns="0" bIns="0">
+            <a:spAutoFit/>
+          </a:bodyPr>
+          <a:lstStyle/>
+          <a:p>
+            <a:pPr algn="l">
+              <a:lnSpc>
+                <a:spcPct val="115000"/>
+              </a:lnSpc>
+            </a:pPr>
+            <a:r>
+              <a:rPr sz="1000" b="1" i="0">
+                <a:solidFill>
+                  <a:srgbClr val="B6142E"/>
+                </a:solidFill>
+                <a:latin typeface="Helvetica Neue"/>
+              </a:rPr>
+              <a:t>BACKGROUND</a:t>
+            </a:r>
+          </a:p>
+        </p:txBody>
+      </p:sp>
+      <p:sp>
+        <p:nvSpPr>
+          <p:cNvPr id="10" name="TextBox 9"/>
+          <p:cNvSpPr txBox="1"/>
+          <p:nvPr/>
+        </p:nvSpPr>
+        <p:spPr>
+          <a:xfrm>
+            <a:off x="502920" y="2148840"/>
+            <a:ext cx="6400800" cy="3840480"/>
+          </a:xfrm>
+          <a:prstGeom prst="rect">
+            <a:avLst/>
+          </a:prstGeom>
+          <a:noFill/>
+        </p:spPr>
+        <p:txBody>
+          <a:bodyPr wrap="square" anchor="t" lIns="0" rIns="0" tIns="0" bIns="0">
+            <a:spAutoFit/>
+          </a:bodyPr>
+          <a:lstStyle/>
+          <a:p>
+            <a:pPr algn="l">
+              <a:lnSpc>
+                <a:spcPct val="115000"/>
+              </a:lnSpc>
+            </a:pPr>
+            <a:r>
+              <a:rPr sz="1200" b="0" i="0">
+                <a:solidFill>
+                  <a:srgbClr val="1B1F29"/>
+                </a:solidFill>
+                <a:latin typeface="Helvetica Neue"/>
+              </a:rPr>
+              <a:t/>
+            </a:r>
+          </a:p>
+          <a:p>
+            <a:pPr algn="l">
+              <a:lnSpc>
+                <a:spcPct val="135000"/>
+              </a:lnSpc>
+              <a:spcBef>
+                <a:spcPts val="0"/>
+              </a:spcBef>
+            </a:pPr>
+            <a:r>
+              <a:rPr sz="1250" b="0" i="0">
+                <a:solidFill>
+                  <a:srgbClr val="1B1F29"/>
+                </a:solidFill>
+                <a:latin typeface="Helvetica Neue"/>
+              </a:rPr>
+              <a:t>EE M.Sc. candidate at Politecnico di Milano, technical concentration in power electronics and control.</a:t>
+            </a:r>
+          </a:p>
+          <a:p>
+            <a:pPr algn="l">
+              <a:lnSpc>
+                <a:spcPct val="135000"/>
+              </a:lnSpc>
+              <a:spcBef>
+                <a:spcPts val="1000"/>
+              </a:spcBef>
+            </a:pPr>
+            <a:r>
+              <a:rPr sz="1250" b="0" i="0">
+                <a:solidFill>
+                  <a:srgbClr val="1B1F29"/>
+                </a:solidFill>
+                <a:latin typeface="Helvetica Neue"/>
+              </a:rPr>
+              <a:t>Most recent project: EMI filter design for a switched-mode converter — direct hands-on exposure to the components and end-markets PE capital is currently flowing into.</a:t>
+            </a:r>
+          </a:p>
+          <a:p>
+            <a:pPr algn="l">
+              <a:lnSpc>
+                <a:spcPct val="135000"/>
+              </a:lnSpc>
+              <a:spcBef>
+                <a:spcPts val="1000"/>
+              </a:spcBef>
+            </a:pPr>
+            <a:r>
+              <a:rPr sz="1250" b="0" i="0">
+                <a:solidFill>
+                  <a:srgbClr val="1B1F29"/>
+                </a:solidFill>
+                <a:latin typeface="Helvetica Neue"/>
+              </a:rPr>
+              <a:t>Why fund finance, why now: the analytical reflexes from EE — sensitivity, decomposition, stress testing — are the same ones NAV underwriting needs. And the sectors where NAV facilities are growing fastest in 2026 are exactly the ones where engineering literacy at the desk would differentiate the bank.</a:t>
+            </a:r>
+          </a:p>
+        </p:txBody>
+      </p:sp>
+      <p:sp>
+        <p:nvSpPr>
+          <p:cNvPr id="11" name="Rectangle 10"/>
+          <p:cNvSpPr/>
+          <p:nvPr/>
+        </p:nvSpPr>
+        <p:spPr>
+          <a:xfrm>
+            <a:off x="7315200" y="1783080"/>
+            <a:ext cx="4389120" cy="4160520"/>
+          </a:xfrm>
+          <a:prstGeom prst="rect">
+            <a:avLst/>
+          </a:prstGeom>
+          <a:solidFill>
+            <a:srgbClr val="F4F5F7"/>
+          </a:solidFill>
+          <a:ln>
+            <a:noFill/>
+          </a:ln>
+          <a:effectLst/>
+        </p:spPr>
+        <p:style>
+          <a:lnRef idx="1">
+            <a:schemeClr val="accent1"/>
+          </a:lnRef>
+          <a:fillRef idx="3">
+            <a:schemeClr val="accent1"/>
+          </a:fillRef>
+          <a:effectRef idx="2">
+            <a:schemeClr val="accent1"/>
+          </a:effectRef>
+          <a:fontRef idx="minor">
+            <a:schemeClr val="lt1"/>
+          </a:fontRef>
+        </p:style>
+        <p:txBody>
+          <a:bodyPr rtlCol="0" anchor="ctr"/>
+          <a:lstStyle/>
+          <a:p>
+            <a:pPr algn="ctr"/>
+          </a:p>
+        </p:txBody>
+      </p:sp>
+      <p:sp>
+        <p:nvSpPr>
+          <p:cNvPr id="12" name="TextBox 11"/>
+          <p:cNvSpPr txBox="1"/>
+          <p:nvPr/>
+        </p:nvSpPr>
+        <p:spPr>
+          <a:xfrm>
+            <a:off x="7543800" y="1920240"/>
+            <a:ext cx="4114800" cy="320040"/>
+          </a:xfrm>
+          <a:prstGeom prst="rect">
+            <a:avLst/>
+          </a:prstGeom>
+          <a:noFill/>
+        </p:spPr>
+        <p:txBody>
+          <a:bodyPr wrap="square" anchor="t" lIns="0" rIns="0" tIns="0" bIns="0">
+            <a:spAutoFit/>
+          </a:bodyPr>
+          <a:lstStyle/>
+          <a:p>
+            <a:pPr algn="l">
+              <a:lnSpc>
+                <a:spcPct val="115000"/>
+              </a:lnSpc>
+            </a:pPr>
+            <a:r>
+              <a:rPr sz="1000" b="1" i="0">
+                <a:solidFill>
+                  <a:srgbClr val="1F7A3C"/>
+                </a:solidFill>
+                <a:latin typeface="Helvetica Neue"/>
+              </a:rPr>
+              <a:t>WHAT I BRING</a:t>
+            </a:r>
+          </a:p>
+        </p:txBody>
+      </p:sp>
+      <p:sp>
+        <p:nvSpPr>
+          <p:cNvPr id="13" name="TextBox 12"/>
+          <p:cNvSpPr txBox="1"/>
+          <p:nvPr/>
+        </p:nvSpPr>
+        <p:spPr>
+          <a:xfrm>
+            <a:off x="7543800" y="2286000"/>
+            <a:ext cx="4023360" cy="1554480"/>
+          </a:xfrm>
+          <a:prstGeom prst="rect">
+            <a:avLst/>
+          </a:prstGeom>
+          <a:noFill/>
+        </p:spPr>
+        <p:txBody>
+          <a:bodyPr wrap="square" anchor="t" lIns="0" rIns="0" tIns="0" bIns="0">
+            <a:spAutoFit/>
+          </a:bodyPr>
+          <a:lstStyle/>
+          <a:p>
+            <a:pPr algn="l">
+              <a:lnSpc>
+                <a:spcPct val="115000"/>
+              </a:lnSpc>
+            </a:pPr>
+            <a:r>
+              <a:rPr sz="1100" b="0" i="0">
+                <a:solidFill>
+                  <a:srgbClr val="1B1F29"/>
+                </a:solidFill>
+                <a:latin typeface="Helvetica Neue"/>
+              </a:rPr>
+              <a:t/>
+            </a:r>
+          </a:p>
+          <a:p>
+            <a:pPr algn="l">
+              <a:lnSpc>
+                <a:spcPct val="130000"/>
+              </a:lnSpc>
+              <a:spcBef>
+                <a:spcPts val="400"/>
+              </a:spcBef>
+              <a:buChar char="•"/>
+              <a:buFont typeface="Helvetica Neue"/>
+            </a:pPr>
+            <a:r>
+              <a:rPr sz="1150" b="0" i="0">
+                <a:solidFill>
+                  <a:srgbClr val="1B1F29"/>
+                </a:solidFill>
+                <a:latin typeface="Helvetica Neue"/>
+              </a:rPr>
+              <a:t>  Engineering depth in power electronics</a:t>
+            </a:r>
+          </a:p>
+          <a:p>
+            <a:pPr algn="l">
+              <a:lnSpc>
+                <a:spcPct val="130000"/>
+              </a:lnSpc>
+              <a:spcBef>
+                <a:spcPts val="400"/>
+              </a:spcBef>
+              <a:buChar char="•"/>
+              <a:buFont typeface="Helvetica Neue"/>
+            </a:pPr>
+            <a:r>
+              <a:rPr sz="1150" b="0" i="0">
+                <a:solidFill>
+                  <a:srgbClr val="1B1F29"/>
+                </a:solidFill>
+                <a:latin typeface="Helvetica Neue"/>
+              </a:rPr>
+              <a:t>  Python + sensitivity-analysis fluency</a:t>
+            </a:r>
+          </a:p>
+          <a:p>
+            <a:pPr algn="l">
+              <a:lnSpc>
+                <a:spcPct val="130000"/>
+              </a:lnSpc>
+              <a:spcBef>
+                <a:spcPts val="400"/>
+              </a:spcBef>
+              <a:buChar char="•"/>
+              <a:buFont typeface="Helvetica Neue"/>
+            </a:pPr>
+            <a:r>
+              <a:rPr sz="1150" b="0" i="0">
+                <a:solidFill>
+                  <a:srgbClr val="1B1F29"/>
+                </a:solidFill>
+                <a:latin typeface="Helvetica Neue"/>
+              </a:rPr>
+              <a:t>  Reflex for decomposing concentrated risk</a:t>
+            </a:r>
+          </a:p>
+          <a:p>
+            <a:pPr algn="l">
+              <a:lnSpc>
+                <a:spcPct val="130000"/>
+              </a:lnSpc>
+              <a:spcBef>
+                <a:spcPts val="400"/>
+              </a:spcBef>
+              <a:buChar char="•"/>
+              <a:buFont typeface="Helvetica Neue"/>
+            </a:pPr>
+            <a:r>
+              <a:rPr sz="1150" b="0" i="0">
+                <a:solidFill>
+                  <a:srgbClr val="1B1F29"/>
+                </a:solidFill>
+                <a:latin typeface="Helvetica Neue"/>
+              </a:rPr>
+              <a:t>  Willingness to admit what I don't know</a:t>
+            </a:r>
+          </a:p>
+        </p:txBody>
+      </p:sp>
+      <p:sp>
+        <p:nvSpPr>
+          <p:cNvPr id="14" name="TextBox 13"/>
+          <p:cNvSpPr txBox="1"/>
+          <p:nvPr/>
+        </p:nvSpPr>
+        <p:spPr>
+          <a:xfrm>
+            <a:off x="7543800" y="4114800"/>
+            <a:ext cx="4114800" cy="320040"/>
+          </a:xfrm>
+          <a:prstGeom prst="rect">
+            <a:avLst/>
+          </a:prstGeom>
+          <a:noFill/>
+        </p:spPr>
+        <p:txBody>
+          <a:bodyPr wrap="square" anchor="t" lIns="0" rIns="0" tIns="0" bIns="0">
+            <a:spAutoFit/>
+          </a:bodyPr>
+          <a:lstStyle/>
+          <a:p>
+            <a:pPr algn="l">
+              <a:lnSpc>
+                <a:spcPct val="115000"/>
+              </a:lnSpc>
+            </a:pPr>
+            <a:r>
+              <a:rPr sz="1000" b="1" i="0">
+                <a:solidFill>
+                  <a:srgbClr val="A81B1B"/>
+                </a:solidFill>
+                <a:latin typeface="Helvetica Neue"/>
+              </a:rPr>
+              <a:t>WHAT I DON'T (YET)</a:t>
+            </a:r>
+          </a:p>
+        </p:txBody>
+      </p:sp>
+      <p:sp>
+        <p:nvSpPr>
+          <p:cNvPr id="15" name="TextBox 14"/>
+          <p:cNvSpPr txBox="1"/>
+          <p:nvPr/>
+        </p:nvSpPr>
+        <p:spPr>
+          <a:xfrm>
+            <a:off x="7543800" y="4434840"/>
+            <a:ext cx="4023360" cy="1463040"/>
+          </a:xfrm>
+          <a:prstGeom prst="rect">
+            <a:avLst/>
+          </a:prstGeom>
+          <a:noFill/>
+        </p:spPr>
+        <p:txBody>
+          <a:bodyPr wrap="square" anchor="t" lIns="0" rIns="0" tIns="0" bIns="0">
+            <a:spAutoFit/>
+          </a:bodyPr>
+          <a:lstStyle/>
+          <a:p>
+            <a:pPr algn="l">
+              <a:lnSpc>
+                <a:spcPct val="115000"/>
+              </a:lnSpc>
+            </a:pPr>
+            <a:r>
+              <a:rPr sz="1100" b="0" i="0">
+                <a:solidFill>
+                  <a:srgbClr val="1B1F29"/>
+                </a:solidFill>
+                <a:latin typeface="Helvetica Neue"/>
+              </a:rPr>
+              <a:t/>
+            </a:r>
+          </a:p>
+          <a:p>
+            <a:pPr algn="l">
+              <a:lnSpc>
+                <a:spcPct val="130000"/>
+              </a:lnSpc>
+              <a:spcBef>
+                <a:spcPts val="400"/>
+              </a:spcBef>
+              <a:buChar char="•"/>
+              <a:buFont typeface="Helvetica Neue"/>
+            </a:pPr>
+            <a:r>
+              <a:rPr sz="1150" b="0" i="0">
+                <a:solidFill>
+                  <a:srgbClr val="1B1F29"/>
+                </a:solidFill>
+                <a:latin typeface="Helvetica Neue"/>
+              </a:rPr>
+              <a:t>  Transaction experience on NAV deals</a:t>
+            </a:r>
+          </a:p>
+          <a:p>
+            <a:pPr algn="l">
+              <a:lnSpc>
+                <a:spcPct val="130000"/>
+              </a:lnSpc>
+              <a:spcBef>
+                <a:spcPts val="400"/>
+              </a:spcBef>
+              <a:buChar char="•"/>
+              <a:buFont typeface="Helvetica Neue"/>
+            </a:pPr>
+            <a:r>
+              <a:rPr sz="1150" b="0" i="0">
+                <a:solidFill>
+                  <a:srgbClr val="1B1F29"/>
+                </a:solidFill>
+                <a:latin typeface="Helvetica Neue"/>
+              </a:rPr>
+              <a:t>  Legal / credit-document grammar</a:t>
+            </a:r>
+          </a:p>
+          <a:p>
+            <a:pPr algn="l">
+              <a:lnSpc>
+                <a:spcPct val="130000"/>
+              </a:lnSpc>
+              <a:spcBef>
+                <a:spcPts val="400"/>
+              </a:spcBef>
+              <a:buChar char="•"/>
+              <a:buFont typeface="Helvetica Neue"/>
+            </a:pPr>
+            <a:r>
+              <a:rPr sz="1150" b="0" i="0">
+                <a:solidFill>
+                  <a:srgbClr val="1B1F29"/>
+                </a:solidFill>
+                <a:latin typeface="Helvetica Neue"/>
+              </a:rPr>
+              <a:t>  Workout mechanics of facility breaches</a:t>
+            </a:r>
+          </a:p>
+          <a:p>
+            <a:pPr algn="l">
+              <a:lnSpc>
+                <a:spcPct val="130000"/>
+              </a:lnSpc>
+              <a:spcBef>
+                <a:spcPts val="400"/>
+              </a:spcBef>
+              <a:buChar char="•"/>
+              <a:buFont typeface="Helvetica Neue"/>
+            </a:pPr>
+            <a:r>
+              <a:rPr sz="1150" b="0" i="0">
+                <a:solidFill>
+                  <a:srgbClr val="1B1F29"/>
+                </a:solidFill>
+                <a:latin typeface="Helvetica Neue"/>
+              </a:rPr>
+              <a:t>  Desk-level pricing conventions</a:t>
+            </a:r>
+          </a:p>
+        </p:txBody>
+      </p:sp>
+    </p:spTree>
+  </p:cSld>
+  <p:clrMapOvr>
+    <a:masterClrMapping/>
+  </p:clrMapOvr>
+</p:sld>
+</file>
+
+<file path=ppt/slides/slide13.xml><?xml version="1.0" encoding="utf-8"?>
+<p:sld xmlns:a="http://schemas.openxmlformats.org/drawingml/2006/main" xmlns:p="http://schemas.openxmlformats.org/presentationml/2006/main" xmlns:r="http://schemas.openxmlformats.org/officeDocument/2006/relationships">
+  <p:cSld>
+    <p:spTree>
+      <p:nvGrpSpPr>
+        <p:cNvPr id="1" name=""/>
+        <p:cNvGrpSpPr/>
+        <p:nvPr/>
+      </p:nvGrpSpPr>
+      <p:grpSpPr/>
+      <p:sp>
+        <p:nvSpPr>
+          <p:cNvPr id="2" name="Rectangle 1"/>
+          <p:cNvSpPr/>
+          <p:nvPr/>
+        </p:nvSpPr>
+        <p:spPr>
+          <a:xfrm>
+            <a:off x="0" y="0"/>
             <a:ext cx="12191695" cy="6858000"/>
           </a:xfrm>
           <a:prstGeom prst="rect">
@@ -5683,7 +7341,7 @@
                 </a:solidFill>
                 <a:latin typeface="Helvetica Neue"/>
               </a:rPr>
-              <a:t>2 / 12</a:t>
+              <a:t>2 / 13</a:t>
             </a:r>
           </a:p>
         </p:txBody>
@@ -6337,7 +7995,7 @@
                 </a:solidFill>
                 <a:latin typeface="Helvetica Neue"/>
               </a:rPr>
-              <a:t>3 / 12</a:t>
+              <a:t>3 / 13</a:t>
             </a:r>
           </a:p>
         </p:txBody>
@@ -6950,7 +8608,7 @@
                 </a:solidFill>
                 <a:latin typeface="Helvetica Neue"/>
               </a:rPr>
-              <a:t>4 / 12</a:t>
+              <a:t>4 / 13</a:t>
             </a:r>
           </a:p>
         </p:txBody>
@@ -8263,7 +9921,7 @@
                 </a:solidFill>
                 <a:latin typeface="Helvetica Neue"/>
               </a:rPr>
-              <a:t>5 / 12</a:t>
+              <a:t>5 / 13</a:t>
             </a:r>
           </a:p>
         </p:txBody>
@@ -8729,7 +10387,7 @@
                 </a:solidFill>
                 <a:latin typeface="Helvetica Neue"/>
               </a:rPr>
-              <a:t>6 / 12</a:t>
+              <a:t>6 / 13</a:t>
             </a:r>
           </a:p>
         </p:txBody>
@@ -10130,7 +11788,7 @@
                 </a:solidFill>
                 <a:latin typeface="Helvetica Neue"/>
               </a:rPr>
-              <a:t>7 / 12</a:t>
+              <a:t>7 / 13</a:t>
             </a:r>
           </a:p>
         </p:txBody>
@@ -11584,7 +13242,7 @@
                 </a:solidFill>
                 <a:latin typeface="Helvetica Neue"/>
               </a:rPr>
-              <a:t>8 / 12</a:t>
+              <a:t>8 / 13</a:t>
             </a:r>
           </a:p>
         </p:txBody>
@@ -11974,7 +13632,7 @@
                 </a:solidFill>
                 <a:latin typeface="Helvetica Neue"/>
               </a:rPr>
-              <a:t>9 / 12</a:t>
+              <a:t>9 / 13</a:t>
             </a:r>
           </a:p>
         </p:txBody>

</xml_diff>